<commit_message>
feat: add reliability moat failure atlas
</commit_message>
<xml_diff>
--- a/docs/submission/AgentGuard-CI-deck.pptx
+++ b/docs/submission/AgentGuard-CI-deck.pptx
@@ -14,6 +14,7 @@
     <p:sldId id="262" r:id="rId13"/>
     <p:sldId id="263" r:id="rId14"/>
     <p:sldId id="264" r:id="rId15"/>
+    <p:sldId id="265" r:id="rId16"/>
   </p:sldIdLst>
   <p:sldSz cx="9144000" cy="6858000" type="screen4x3"/>
   <p:notesSz cx="6858000" cy="9144000"/>
@@ -3268,7 +3269,7 @@
               </a:defRPr>
             </a:pPr>
             <a:r>
-              <a:t>Reliability testing for AI code-fixing agents</a:t>
+              <a:t>Reliability firewall for AI code-fixing agents</a:t>
             </a:r>
           </a:p>
         </p:txBody>
@@ -3303,7 +3304,231 @@
               </a:defRPr>
             </a:pPr>
             <a:r>
-              <a:t>A governed scenario runner that turns agent fixes into auditable Test Cloud evidence.</a:t>
+              <a:t>A 24-mode failure atlas that turns agent fixes into auditable Test Cloud evidence.</a:t>
+            </a:r>
+          </a:p>
+        </p:txBody>
+      </p:sp>
+    </p:spTree>
+  </p:cSld>
+  <p:clrMapOvr>
+    <a:masterClrMapping/>
+  </p:clrMapOvr>
+</p:sld>
+</file>
+
+<file path=ppt/slides/slide10.xml><?xml version="1.0" encoding="utf-8"?>
+<p:sld xmlns:a="http://schemas.openxmlformats.org/drawingml/2006/main" xmlns:p="http://schemas.openxmlformats.org/presentationml/2006/main" xmlns:r="http://schemas.openxmlformats.org/officeDocument/2006/relationships">
+  <p:cSld>
+    <p:bg>
+      <p:bgPr>
+        <a:solidFill>
+          <a:srgbClr val="FFFFFF"/>
+        </a:solidFill>
+        <a:effectLst/>
+      </p:bgPr>
+    </p:bg>
+    <p:spTree>
+      <p:nvGrpSpPr>
+        <p:cNvPr id="1" name=""/>
+        <p:cNvGrpSpPr/>
+        <p:nvPr/>
+      </p:nvGrpSpPr>
+      <p:grpSpPr/>
+      <p:sp>
+        <p:nvSpPr>
+          <p:cNvPr id="2" name="TextBox 1"/>
+          <p:cNvSpPr txBox="1"/>
+          <p:nvPr/>
+        </p:nvSpPr>
+        <p:spPr>
+          <a:xfrm>
+            <a:off x="548640" y="502920"/>
+            <a:ext cx="7863840" cy="548640"/>
+          </a:xfrm>
+          <a:prstGeom prst="rect">
+            <a:avLst/>
+          </a:prstGeom>
+          <a:noFill/>
+        </p:spPr>
+        <p:txBody>
+          <a:bodyPr wrap="none">
+            <a:spAutoFit/>
+          </a:bodyPr>
+          <a:lstStyle/>
+          <a:p>
+            <a:pPr>
+              <a:defRPr b="1" sz="3200">
+                <a:solidFill>
+                  <a:srgbClr val="101F33"/>
+                </a:solidFill>
+              </a:defRPr>
+            </a:pPr>
+            <a:r>
+              <a:t>Next Steps</a:t>
+            </a:r>
+          </a:p>
+        </p:txBody>
+      </p:sp>
+      <p:sp>
+        <p:nvSpPr>
+          <p:cNvPr id="3" name="TextBox 2"/>
+          <p:cNvSpPr txBox="1"/>
+          <p:nvPr/>
+        </p:nvSpPr>
+        <p:spPr>
+          <a:xfrm>
+            <a:off x="685800" y="1417320"/>
+            <a:ext cx="7589520" cy="4297680"/>
+          </a:xfrm>
+          <a:prstGeom prst="rect">
+            <a:avLst/>
+          </a:prstGeom>
+          <a:noFill/>
+        </p:spPr>
+        <p:txBody>
+          <a:bodyPr wrap="none">
+            <a:spAutoFit/>
+          </a:bodyPr>
+          <a:lstStyle/>
+          <a:p>
+            <a:pPr>
+              <a:spcAft>
+                <a:spcPts val="900"/>
+              </a:spcAft>
+              <a:defRPr sz="1800">
+                <a:solidFill>
+                  <a:srgbClr val="435062"/>
+                </a:solidFill>
+              </a:defRPr>
+            </a:pPr>
+            <a:r>
+              <a:t>Connect the runner to UiPath Orchestrator and Test Cloud APIs.</a:t>
+            </a:r>
+          </a:p>
+          <a:p>
+            <a:pPr>
+              <a:spcAft>
+                <a:spcPts val="900"/>
+              </a:spcAft>
+              <a:defRPr sz="1800">
+                <a:solidFill>
+                  <a:srgbClr val="435062"/>
+                </a:solidFill>
+              </a:defRPr>
+            </a:pPr>
+            <a:r>
+              <a:t>Add adapters for more coding agents and enterprise CI providers.</a:t>
+            </a:r>
+          </a:p>
+          <a:p>
+            <a:pPr>
+              <a:spcAft>
+                <a:spcPts val="900"/>
+              </a:spcAft>
+              <a:defRPr sz="1800">
+                <a:solidFill>
+                  <a:srgbClr val="435062"/>
+                </a:solidFill>
+              </a:defRPr>
+            </a:pPr>
+            <a:r>
+              <a:t>Add enterprise policy packs for security, compliance, and release governance.</a:t>
+            </a:r>
+          </a:p>
+          <a:p>
+            <a:pPr>
+              <a:spcAft>
+                <a:spcPts val="900"/>
+              </a:spcAft>
+              <a:defRPr sz="1800">
+                <a:solidFill>
+                  <a:srgbClr val="435062"/>
+                </a:solidFill>
+              </a:defRPr>
+            </a:pPr>
+            <a:r>
+              <a:t>Use the same evidence loop for production agent release gates.</a:t>
+            </a:r>
+          </a:p>
+        </p:txBody>
+      </p:sp>
+      <p:sp>
+        <p:nvSpPr>
+          <p:cNvPr id="4" name="Rectangle 3"/>
+          <p:cNvSpPr/>
+          <p:nvPr/>
+        </p:nvSpPr>
+        <p:spPr>
+          <a:xfrm>
+            <a:off x="0" y="6400800"/>
+            <a:ext cx="9144000" cy="73152"/>
+          </a:xfrm>
+          <a:prstGeom prst="rect">
+            <a:avLst/>
+          </a:prstGeom>
+          <a:solidFill>
+            <a:srgbClr val="76D7C4"/>
+          </a:solidFill>
+          <a:ln>
+            <a:solidFill>
+              <a:srgbClr val="76D7C4"/>
+            </a:solidFill>
+          </a:ln>
+        </p:spPr>
+        <p:style>
+          <a:lnRef idx="1">
+            <a:schemeClr val="accent1"/>
+          </a:lnRef>
+          <a:fillRef idx="3">
+            <a:schemeClr val="accent1"/>
+          </a:fillRef>
+          <a:effectRef idx="2">
+            <a:schemeClr val="accent1"/>
+          </a:effectRef>
+          <a:fontRef idx="minor">
+            <a:schemeClr val="lt1"/>
+          </a:fontRef>
+        </p:style>
+        <p:txBody>
+          <a:bodyPr rtlCol="0" anchor="ctr"/>
+          <a:lstStyle/>
+          <a:p>
+            <a:pPr algn="ctr"/>
+          </a:p>
+        </p:txBody>
+      </p:sp>
+      <p:sp>
+        <p:nvSpPr>
+          <p:cNvPr id="5" name="TextBox 4"/>
+          <p:cNvSpPr txBox="1"/>
+          <p:nvPr/>
+        </p:nvSpPr>
+        <p:spPr>
+          <a:xfrm>
+            <a:off x="548640" y="6473952"/>
+            <a:ext cx="8046720" cy="228600"/>
+          </a:xfrm>
+          <a:prstGeom prst="rect">
+            <a:avLst/>
+          </a:prstGeom>
+          <a:noFill/>
+        </p:spPr>
+        <p:txBody>
+          <a:bodyPr wrap="none">
+            <a:spAutoFit/>
+          </a:bodyPr>
+          <a:lstStyle/>
+          <a:p>
+            <a:pPr>
+              <a:defRPr sz="900">
+                <a:solidFill>
+                  <a:srgbClr val="435062"/>
+                </a:solidFill>
+              </a:defRPr>
+            </a:pPr>
+            <a:r>
+              <a:t>AgentGuard CI | UiPath AgentHack Track 3: UiPath Test Cloud</a:t>
             </a:r>
           </a:p>
         </p:txBody>
@@ -3839,7 +4064,7 @@
               </a:defRPr>
             </a:pPr>
             <a:r>
-              <a:t>AgentGuard CI runs controlled failure scenarios against a React and Express issue tracker.</a:t>
+              <a:t>AgentGuard CI runs 24 controlled failure scenarios against a React and Express issue tracker.</a:t>
             </a:r>
           </a:p>
           <a:p>
@@ -4306,7 +4531,7 @@
               </a:defRPr>
             </a:pPr>
             <a:r>
-              <a:t>agentguard-runs/&lt;scenario&gt;/result.json</a:t>
+              <a:t>agentguard-runs/&lt;scenario&gt;/report.json</a:t>
             </a:r>
           </a:p>
           <a:p>
@@ -4716,7 +4941,7 @@
               </a:defRPr>
             </a:pPr>
             <a:r>
-              <a:t>Scenario Matrix</a:t>
+              <a:t>Failure Atlas</a:t>
             </a:r>
           </a:p>
         </p:txBody>
@@ -4852,6 +5077,36 @@
               <a:t>backend-triage: expected score 5/5</a:t>
             </a:r>
           </a:p>
+          <a:p>
+            <a:pPr>
+              <a:spcAft>
+                <a:spcPts val="900"/>
+              </a:spcAft>
+              <a:defRPr sz="1500">
+                <a:solidFill>
+                  <a:srgbClr val="435062"/>
+                </a:solidFill>
+              </a:defRPr>
+            </a:pPr>
+            <a:r>
+              <a:t>input-validation-gap: expected score 5/5</a:t>
+            </a:r>
+          </a:p>
+          <a:p>
+            <a:pPr>
+              <a:spcAft>
+                <a:spcPts val="900"/>
+              </a:spcAft>
+              <a:defRPr sz="1500">
+                <a:solidFill>
+                  <a:srgbClr val="435062"/>
+                </a:solidFill>
+              </a:defRPr>
+            </a:pPr>
+            <a:r>
+              <a:t>timezone-edge-case: expected score 5/5</a:t>
+            </a:r>
+          </a:p>
         </p:txBody>
       </p:sp>
       <p:sp>
@@ -4967,7 +5222,7 @@
               </a:defRPr>
             </a:pPr>
             <a:r>
-              <a:t>test-integrity-guard: fails by design when tests are weakened</a:t>
+              <a:t>prompt-injection-override: blocks policy override attempts</a:t>
             </a:r>
           </a:p>
           <a:p>
@@ -4982,7 +5237,37 @@
               </a:defRPr>
             </a:pPr>
             <a:r>
-              <a:t>unsafe-diff-guard: fails by design on unrelated risky edits</a:t>
+              <a:t>snapshot-blessing-abuse: blocks golden-output laundering</a:t>
+            </a:r>
+          </a:p>
+          <a:p>
+            <a:pPr>
+              <a:spcAft>
+                <a:spcPts val="900"/>
+              </a:spcAft>
+              <a:defRPr sz="1500">
+                <a:solidFill>
+                  <a:srgbClr val="435062"/>
+                </a:solidFill>
+              </a:defRPr>
+            </a:pPr>
+            <a:r>
+              <a:t>large-refactor-drift: blocks over-broad repairs</a:t>
+            </a:r>
+          </a:p>
+          <a:p>
+            <a:pPr>
+              <a:spcAft>
+                <a:spcPts val="900"/>
+              </a:spcAft>
+              <a:defRPr sz="1500">
+                <a:solidFill>
+                  <a:srgbClr val="435062"/>
+                </a:solidFill>
+              </a:defRPr>
+            </a:pPr>
+            <a:r>
+              <a:t>nondeterministic-random-fix: detects random workaround drift</a:t>
             </a:r>
           </a:p>
         </p:txBody>
@@ -5123,7 +5408,7 @@
               </a:defRPr>
             </a:pPr>
             <a:r>
-              <a:t>UiPath Test Cloud Fit</a:t>
+              <a:t>Competitive Moat</a:t>
             </a:r>
           </a:p>
         </p:txBody>
@@ -5161,7 +5446,7 @@
               </a:defRPr>
             </a:pPr>
             <a:r>
-              <a:t>Each AgentGuard scenario maps to a Test Cloud test case.</a:t>
+              <a:t>Predictive test selection runs fewer tests; AgentGuard adds agent behavior gates.</a:t>
             </a:r>
           </a:p>
           <a:p>
@@ -5176,7 +5461,7 @@
               </a:defRPr>
             </a:pPr>
             <a:r>
-              <a:t>JUnit and Markdown reports become attached execution evidence.</a:t>
+              <a:t>Test observability explains failures; AgentGuard decides promote, review, or hard block.</a:t>
             </a:r>
           </a:p>
           <a:p>
@@ -5191,7 +5476,7 @@
               </a:defRPr>
             </a:pPr>
             <a:r>
-              <a:t>Governance failures are useful failures: they route unsafe agent behavior to human review.</a:t>
+              <a:t>CI optimization saves time; AgentGuard optimizes the evidence loop around autonomous-code risk.</a:t>
             </a:r>
           </a:p>
           <a:p>
@@ -5206,7 +5491,7 @@
               </a:defRPr>
             </a:pPr>
             <a:r>
-              <a:t>The result is a repeatable quality gate for AI agents, not a one-off demo.</a:t>
+              <a:t>Risk-based testing prioritizes releases; AgentGuard specializes the taxonomy for coding-agent failures.</a:t>
             </a:r>
           </a:p>
         </p:txBody>
@@ -5347,7 +5632,7 @@
               </a:defRPr>
             </a:pPr>
             <a:r>
-              <a:t>Demo Flow</a:t>
+              <a:t>UiPath Test Cloud Fit</a:t>
             </a:r>
           </a:p>
         </p:txBody>
@@ -5385,7 +5670,7 @@
               </a:defRPr>
             </a:pPr>
             <a:r>
-              <a:t>1. Show the Issue Tracker sample app and CI failure.</a:t>
+              <a:t>Each AgentGuard scenario maps to a Test Cloud test case.</a:t>
             </a:r>
           </a:p>
           <a:p>
@@ -5400,7 +5685,7 @@
               </a:defRPr>
             </a:pPr>
             <a:r>
-              <a:t>2. Run npm run agentguard:scenario -- --scenario frontend-contract.</a:t>
+              <a:t>JUnit and Markdown reports become attached execution evidence.</a:t>
             </a:r>
           </a:p>
           <a:p>
@@ -5415,7 +5700,7 @@
               </a:defRPr>
             </a:pPr>
             <a:r>
-              <a:t>3. Show a 5/5 safe repair with scoped changes.</a:t>
+              <a:t>Governance failures are useful failures: they route unsafe agent behavior to human review.</a:t>
             </a:r>
           </a:p>
           <a:p>
@@ -5430,22 +5715,7 @@
               </a:defRPr>
             </a:pPr>
             <a:r>
-              <a:t>4. Run unsafe-diff-guard and show governance failure evidence.</a:t>
-            </a:r>
-          </a:p>
-          <a:p>
-            <a:pPr>
-              <a:spcAft>
-                <a:spcPts val="900"/>
-              </a:spcAft>
-              <a:defRPr sz="1800">
-                <a:solidFill>
-                  <a:srgbClr val="435062"/>
-                </a:solidFill>
-              </a:defRPr>
-            </a:pPr>
-            <a:r>
-              <a:t>5. Connect the reports to UiPath Test Cloud cases.</a:t>
+              <a:t>The result is a repeatable quality gate for AI agents, not a one-off demo.</a:t>
             </a:r>
           </a:p>
         </p:txBody>
@@ -5586,7 +5856,7 @@
               </a:defRPr>
             </a:pPr>
             <a:r>
-              <a:t>Next Steps</a:t>
+              <a:t>Demo Flow</a:t>
             </a:r>
           </a:p>
         </p:txBody>
@@ -5624,7 +5894,7 @@
               </a:defRPr>
             </a:pPr>
             <a:r>
-              <a:t>Connect the runner to UiPath Orchestrator and Test Cloud APIs.</a:t>
+              <a:t>1. Show the Issue Tracker sample app and CI failure.</a:t>
             </a:r>
           </a:p>
           <a:p>
@@ -5639,7 +5909,7 @@
               </a:defRPr>
             </a:pPr>
             <a:r>
-              <a:t>Add adapters for more coding agents and enterprise CI providers.</a:t>
+              <a:t>2. Run npm run agentguard:suite.</a:t>
             </a:r>
           </a:p>
           <a:p>
@@ -5654,7 +5924,7 @@
               </a:defRPr>
             </a:pPr>
             <a:r>
-              <a:t>Expand the scenario library for security, data integrity, and compliance workflows.</a:t>
+              <a:t>3. Show 7/24 auto-promotions, 17 review routes, 12 hard blocks, and 73% gate pass rate.</a:t>
             </a:r>
           </a:p>
           <a:p>
@@ -5669,7 +5939,22 @@
               </a:defRPr>
             </a:pPr>
             <a:r>
-              <a:t>Use the same evidence loop for production agent release gates.</a:t>
+              <a:t>4. Open unsafe-diff-guard or prompt-injection-override and show governance failure evidence.</a:t>
+            </a:r>
+          </a:p>
+          <a:p>
+            <a:pPr>
+              <a:spcAft>
+                <a:spcPts val="900"/>
+              </a:spcAft>
+              <a:defRPr sz="1800">
+                <a:solidFill>
+                  <a:srgbClr val="435062"/>
+                </a:solidFill>
+              </a:defRPr>
+            </a:pPr>
+            <a:r>
+              <a:t>5. Connect the reports and CSV to UiPath Test Cloud cases.</a:t>
             </a:r>
           </a:p>
         </p:txBody>

</xml_diff>

<commit_message>
feat: add risk assurance scoring
</commit_message>
<xml_diff>
--- a/docs/submission/AgentGuard-CI-deck.pptx
+++ b/docs/submission/AgentGuard-CI-deck.pptx
@@ -15,6 +15,7 @@
     <p:sldId id="263" r:id="rId14"/>
     <p:sldId id="264" r:id="rId15"/>
     <p:sldId id="265" r:id="rId16"/>
+    <p:sldId id="266" r:id="rId17"/>
   </p:sldIdLst>
   <p:sldSz cx="9144000" cy="6858000" type="screen4x3"/>
   <p:notesSz cx="6858000" cy="9144000"/>
@@ -3365,6 +3366,245 @@
               </a:defRPr>
             </a:pPr>
             <a:r>
+              <a:t>Demo Flow</a:t>
+            </a:r>
+          </a:p>
+        </p:txBody>
+      </p:sp>
+      <p:sp>
+        <p:nvSpPr>
+          <p:cNvPr id="3" name="TextBox 2"/>
+          <p:cNvSpPr txBox="1"/>
+          <p:nvPr/>
+        </p:nvSpPr>
+        <p:spPr>
+          <a:xfrm>
+            <a:off x="685800" y="1417320"/>
+            <a:ext cx="7589520" cy="4297680"/>
+          </a:xfrm>
+          <a:prstGeom prst="rect">
+            <a:avLst/>
+          </a:prstGeom>
+          <a:noFill/>
+        </p:spPr>
+        <p:txBody>
+          <a:bodyPr wrap="none">
+            <a:spAutoFit/>
+          </a:bodyPr>
+          <a:lstStyle/>
+          <a:p>
+            <a:pPr>
+              <a:spcAft>
+                <a:spcPts val="900"/>
+              </a:spcAft>
+              <a:defRPr sz="1800">
+                <a:solidFill>
+                  <a:srgbClr val="435062"/>
+                </a:solidFill>
+              </a:defRPr>
+            </a:pPr>
+            <a:r>
+              <a:t>1. Show the Issue Tracker sample app and CI failure.</a:t>
+            </a:r>
+          </a:p>
+          <a:p>
+            <a:pPr>
+              <a:spcAft>
+                <a:spcPts val="900"/>
+              </a:spcAft>
+              <a:defRPr sz="1800">
+                <a:solidFill>
+                  <a:srgbClr val="435062"/>
+                </a:solidFill>
+              </a:defRPr>
+            </a:pPr>
+            <a:r>
+              <a:t>2. Run npm run agentguard:suite.</a:t>
+            </a:r>
+          </a:p>
+          <a:p>
+            <a:pPr>
+              <a:spcAft>
+                <a:spcPts val="900"/>
+              </a:spcAft>
+              <a:defRPr sz="1800">
+                <a:solidFill>
+                  <a:srgbClr val="435062"/>
+                </a:solidFill>
+              </a:defRPr>
+            </a:pPr>
+            <a:r>
+              <a:t>3. Show 7/24 auto-promotions, 17 review routes, 12 hard blocks, and 73% gate pass rate.</a:t>
+            </a:r>
+          </a:p>
+          <a:p>
+            <a:pPr>
+              <a:spcAft>
+                <a:spcPts val="900"/>
+              </a:spcAft>
+              <a:defRPr sz="1800">
+                <a:solidFill>
+                  <a:srgbClr val="435062"/>
+                </a:solidFill>
+              </a:defRPr>
+            </a:pPr>
+            <a:r>
+              <a:t>4. Open unsafe-diff-guard or prompt-injection-override and show governance failure evidence.</a:t>
+            </a:r>
+          </a:p>
+          <a:p>
+            <a:pPr>
+              <a:spcAft>
+                <a:spcPts val="900"/>
+              </a:spcAft>
+              <a:defRPr sz="1800">
+                <a:solidFill>
+                  <a:srgbClr val="435062"/>
+                </a:solidFill>
+              </a:defRPr>
+            </a:pPr>
+            <a:r>
+              <a:t>5. Connect the reports and CSV to UiPath Test Cloud cases.</a:t>
+            </a:r>
+          </a:p>
+        </p:txBody>
+      </p:sp>
+      <p:sp>
+        <p:nvSpPr>
+          <p:cNvPr id="4" name="Rectangle 3"/>
+          <p:cNvSpPr/>
+          <p:nvPr/>
+        </p:nvSpPr>
+        <p:spPr>
+          <a:xfrm>
+            <a:off x="0" y="6400800"/>
+            <a:ext cx="9144000" cy="73152"/>
+          </a:xfrm>
+          <a:prstGeom prst="rect">
+            <a:avLst/>
+          </a:prstGeom>
+          <a:solidFill>
+            <a:srgbClr val="76D7C4"/>
+          </a:solidFill>
+          <a:ln>
+            <a:solidFill>
+              <a:srgbClr val="76D7C4"/>
+            </a:solidFill>
+          </a:ln>
+        </p:spPr>
+        <p:style>
+          <a:lnRef idx="1">
+            <a:schemeClr val="accent1"/>
+          </a:lnRef>
+          <a:fillRef idx="3">
+            <a:schemeClr val="accent1"/>
+          </a:fillRef>
+          <a:effectRef idx="2">
+            <a:schemeClr val="accent1"/>
+          </a:effectRef>
+          <a:fontRef idx="minor">
+            <a:schemeClr val="lt1"/>
+          </a:fontRef>
+        </p:style>
+        <p:txBody>
+          <a:bodyPr rtlCol="0" anchor="ctr"/>
+          <a:lstStyle/>
+          <a:p>
+            <a:pPr algn="ctr"/>
+          </a:p>
+        </p:txBody>
+      </p:sp>
+      <p:sp>
+        <p:nvSpPr>
+          <p:cNvPr id="5" name="TextBox 4"/>
+          <p:cNvSpPr txBox="1"/>
+          <p:nvPr/>
+        </p:nvSpPr>
+        <p:spPr>
+          <a:xfrm>
+            <a:off x="548640" y="6473952"/>
+            <a:ext cx="8046720" cy="228600"/>
+          </a:xfrm>
+          <a:prstGeom prst="rect">
+            <a:avLst/>
+          </a:prstGeom>
+          <a:noFill/>
+        </p:spPr>
+        <p:txBody>
+          <a:bodyPr wrap="none">
+            <a:spAutoFit/>
+          </a:bodyPr>
+          <a:lstStyle/>
+          <a:p>
+            <a:pPr>
+              <a:defRPr sz="900">
+                <a:solidFill>
+                  <a:srgbClr val="435062"/>
+                </a:solidFill>
+              </a:defRPr>
+            </a:pPr>
+            <a:r>
+              <a:t>AgentGuard CI | UiPath AgentHack Track 3: UiPath Test Cloud</a:t>
+            </a:r>
+          </a:p>
+        </p:txBody>
+      </p:sp>
+    </p:spTree>
+  </p:cSld>
+  <p:clrMapOvr>
+    <a:masterClrMapping/>
+  </p:clrMapOvr>
+</p:sld>
+</file>
+
+<file path=ppt/slides/slide11.xml><?xml version="1.0" encoding="utf-8"?>
+<p:sld xmlns:a="http://schemas.openxmlformats.org/drawingml/2006/main" xmlns:p="http://schemas.openxmlformats.org/presentationml/2006/main" xmlns:r="http://schemas.openxmlformats.org/officeDocument/2006/relationships">
+  <p:cSld>
+    <p:bg>
+      <p:bgPr>
+        <a:solidFill>
+          <a:srgbClr val="FFFFFF"/>
+        </a:solidFill>
+        <a:effectLst/>
+      </p:bgPr>
+    </p:bg>
+    <p:spTree>
+      <p:nvGrpSpPr>
+        <p:cNvPr id="1" name=""/>
+        <p:cNvGrpSpPr/>
+        <p:nvPr/>
+      </p:nvGrpSpPr>
+      <p:grpSpPr/>
+      <p:sp>
+        <p:nvSpPr>
+          <p:cNvPr id="2" name="TextBox 1"/>
+          <p:cNvSpPr txBox="1"/>
+          <p:nvPr/>
+        </p:nvSpPr>
+        <p:spPr>
+          <a:xfrm>
+            <a:off x="548640" y="502920"/>
+            <a:ext cx="7863840" cy="548640"/>
+          </a:xfrm>
+          <a:prstGeom prst="rect">
+            <a:avLst/>
+          </a:prstGeom>
+          <a:noFill/>
+        </p:spPr>
+        <p:txBody>
+          <a:bodyPr wrap="none">
+            <a:spAutoFit/>
+          </a:bodyPr>
+          <a:lstStyle/>
+          <a:p>
+            <a:pPr>
+              <a:defRPr b="1" sz="3200">
+                <a:solidFill>
+                  <a:srgbClr val="101F33"/>
+                </a:solidFill>
+              </a:defRPr>
+            </a:pPr>
+            <a:r>
               <a:t>Next Steps</a:t>
             </a:r>
           </a:p>
@@ -5408,7 +5648,7 @@
               </a:defRPr>
             </a:pPr>
             <a:r>
-              <a:t>Competitive Moat</a:t>
+              <a:t>Assurance Case</a:t>
             </a:r>
           </a:p>
         </p:txBody>
@@ -5446,7 +5686,7 @@
               </a:defRPr>
             </a:pPr>
             <a:r>
-              <a:t>Predictive test selection runs fewer tests; AgentGuard adds agent behavior gates.</a:t>
+              <a:t>Each scenario has severity, named owner, control, evidence standard, and risk points.</a:t>
             </a:r>
           </a:p>
           <a:p>
@@ -5461,7 +5701,7 @@
               </a:defRPr>
             </a:pPr>
             <a:r>
-              <a:t>Test observability explains failures; AgentGuard decides promote, review, or hard block.</a:t>
+              <a:t>Full-suite result: 106/131 risk points stopped before promotion.</a:t>
             </a:r>
           </a:p>
           <a:p>
@@ -5476,7 +5716,7 @@
               </a:defRPr>
             </a:pPr>
             <a:r>
-              <a:t>CI optimization saves time; AgentGuard optimizes the evidence loop around autonomous-code risk.</a:t>
+              <a:t>5 critical findings require named-owner approval.</a:t>
             </a:r>
           </a:p>
           <a:p>
@@ -5491,7 +5731,7 @@
               </a:defRPr>
             </a:pPr>
             <a:r>
-              <a:t>Risk-based testing prioritizes releases; AgentGuard specializes the taxonomy for coding-agent failures.</a:t>
+              <a:t>Security Review is the top owner queue with 24 blocked risk points across 3 findings.</a:t>
             </a:r>
           </a:p>
         </p:txBody>
@@ -5632,7 +5872,7 @@
               </a:defRPr>
             </a:pPr>
             <a:r>
-              <a:t>UiPath Test Cloud Fit</a:t>
+              <a:t>Competitive Moat</a:t>
             </a:r>
           </a:p>
         </p:txBody>
@@ -5670,7 +5910,7 @@
               </a:defRPr>
             </a:pPr>
             <a:r>
-              <a:t>Each AgentGuard scenario maps to a Test Cloud test case.</a:t>
+              <a:t>Predictive test selection runs fewer tests; AgentGuard adds agent behavior gates.</a:t>
             </a:r>
           </a:p>
           <a:p>
@@ -5685,7 +5925,7 @@
               </a:defRPr>
             </a:pPr>
             <a:r>
-              <a:t>JUnit and Markdown reports become attached execution evidence.</a:t>
+              <a:t>Test observability explains failures; AgentGuard decides promote, review, or hard block.</a:t>
             </a:r>
           </a:p>
           <a:p>
@@ -5700,7 +5940,7 @@
               </a:defRPr>
             </a:pPr>
             <a:r>
-              <a:t>Governance failures are useful failures: they route unsafe agent behavior to human review.</a:t>
+              <a:t>CI optimization saves time; AgentGuard optimizes the evidence loop around autonomous-code risk.</a:t>
             </a:r>
           </a:p>
           <a:p>
@@ -5715,7 +5955,7 @@
               </a:defRPr>
             </a:pPr>
             <a:r>
-              <a:t>The result is a repeatable quality gate for AI agents, not a one-off demo.</a:t>
+              <a:t>Risk-based testing prioritizes releases; AgentGuard specializes the taxonomy for coding-agent failures.</a:t>
             </a:r>
           </a:p>
         </p:txBody>
@@ -5856,7 +6096,7 @@
               </a:defRPr>
             </a:pPr>
             <a:r>
-              <a:t>Demo Flow</a:t>
+              <a:t>UiPath Test Cloud Fit</a:t>
             </a:r>
           </a:p>
         </p:txBody>
@@ -5894,7 +6134,7 @@
               </a:defRPr>
             </a:pPr>
             <a:r>
-              <a:t>1. Show the Issue Tracker sample app and CI failure.</a:t>
+              <a:t>Each AgentGuard scenario maps to a Test Cloud test case.</a:t>
             </a:r>
           </a:p>
           <a:p>
@@ -5909,7 +6149,7 @@
               </a:defRPr>
             </a:pPr>
             <a:r>
-              <a:t>2. Run npm run agentguard:suite.</a:t>
+              <a:t>JUnit and Markdown reports become attached execution evidence.</a:t>
             </a:r>
           </a:p>
           <a:p>
@@ -5924,7 +6164,7 @@
               </a:defRPr>
             </a:pPr>
             <a:r>
-              <a:t>3. Show 7/24 auto-promotions, 17 review routes, 12 hard blocks, and 73% gate pass rate.</a:t>
+              <a:t>Governance failures are useful failures: they route unsafe agent behavior to human review.</a:t>
             </a:r>
           </a:p>
           <a:p>
@@ -5939,22 +6179,7 @@
               </a:defRPr>
             </a:pPr>
             <a:r>
-              <a:t>4. Open unsafe-diff-guard or prompt-injection-override and show governance failure evidence.</a:t>
-            </a:r>
-          </a:p>
-          <a:p>
-            <a:pPr>
-              <a:spcAft>
-                <a:spcPts val="900"/>
-              </a:spcAft>
-              <a:defRPr sz="1800">
-                <a:solidFill>
-                  <a:srgbClr val="435062"/>
-                </a:solidFill>
-              </a:defRPr>
-            </a:pPr>
-            <a:r>
-              <a:t>5. Connect the reports and CSV to UiPath Test Cloud cases.</a:t>
+              <a:t>The result is a repeatable quality gate for AI agents, not a one-off demo.</a:t>
             </a:r>
           </a:p>
         </p:txBody>

</xml_diff>